<commit_message>
Added the final Presentation, Poster and Speech.md
</commit_message>
<xml_diff>
--- a/ppt.pptx
+++ b/ppt.pptx
@@ -626,7 +626,7 @@
           </a:ln>
           <a:extLst>
             <a:ext uri="{C572A759-6A51-4108-AA02-DFA0A04FC94B}">
-              <ma14:wrappingTextBoxFlag xmlns:ma14="http://schemas.microsoft.com/office/mac/drawingml/2011/main" xmlns:a14="http://schemas.microsoft.com/office/drawing/2010/main" xmlns:m="http://schemas.openxmlformats.org/officeDocument/2006/math" xmlns="" val="1"/>
+              <ma14:wrappingTextBoxFlag xmlns="" xmlns:m="http://schemas.openxmlformats.org/officeDocument/2006/math" xmlns:a14="http://schemas.microsoft.com/office/drawing/2010/main" xmlns:ma14="http://schemas.microsoft.com/office/mac/drawingml/2011/main" val="1"/>
             </a:ext>
           </a:extLst>
         </p:spPr>
@@ -663,7 +663,7 @@
           </a:ln>
           <a:extLst>
             <a:ext uri="{C572A759-6A51-4108-AA02-DFA0A04FC94B}">
-              <ma14:wrappingTextBoxFlag xmlns:ma14="http://schemas.microsoft.com/office/mac/drawingml/2011/main" xmlns:a14="http://schemas.microsoft.com/office/drawing/2010/main" xmlns:m="http://schemas.openxmlformats.org/officeDocument/2006/math" xmlns="" val="1"/>
+              <ma14:wrappingTextBoxFlag xmlns="" xmlns:m="http://schemas.openxmlformats.org/officeDocument/2006/math" xmlns:a14="http://schemas.microsoft.com/office/drawing/2010/main" xmlns:ma14="http://schemas.microsoft.com/office/mac/drawingml/2011/main" val="1"/>
             </a:ext>
           </a:extLst>
         </p:spPr>
@@ -1495,7 +1495,7 @@
           </a:ln>
           <a:extLst>
             <a:ext uri="{C572A759-6A51-4108-AA02-DFA0A04FC94B}">
-              <ma14:wrappingTextBoxFlag xmlns:ma14="http://schemas.microsoft.com/office/mac/drawingml/2011/main" xmlns:a14="http://schemas.microsoft.com/office/drawing/2010/main" xmlns:m="http://schemas.openxmlformats.org/officeDocument/2006/math" xmlns="" val="1"/>
+              <ma14:wrappingTextBoxFlag xmlns="" xmlns:m="http://schemas.openxmlformats.org/officeDocument/2006/math" xmlns:a14="http://schemas.microsoft.com/office/drawing/2010/main" xmlns:ma14="http://schemas.microsoft.com/office/mac/drawingml/2011/main" val="1"/>
             </a:ext>
           </a:extLst>
         </p:spPr>
@@ -1541,7 +1541,7 @@
           </a:ln>
           <a:extLst>
             <a:ext uri="{C572A759-6A51-4108-AA02-DFA0A04FC94B}">
-              <ma14:wrappingTextBoxFlag xmlns:ma14="http://schemas.microsoft.com/office/mac/drawingml/2011/main" xmlns:a14="http://schemas.microsoft.com/office/drawing/2010/main" xmlns:m="http://schemas.openxmlformats.org/officeDocument/2006/math" xmlns="" val="1"/>
+              <ma14:wrappingTextBoxFlag xmlns="" xmlns:m="http://schemas.openxmlformats.org/officeDocument/2006/math" xmlns:a14="http://schemas.microsoft.com/office/drawing/2010/main" xmlns:ma14="http://schemas.microsoft.com/office/mac/drawingml/2011/main" val="1"/>
             </a:ext>
           </a:extLst>
         </p:spPr>
@@ -1586,7 +1586,7 @@
           </a:ln>
           <a:extLst>
             <a:ext uri="{C572A759-6A51-4108-AA02-DFA0A04FC94B}">
-              <ma14:wrappingTextBoxFlag xmlns:ma14="http://schemas.microsoft.com/office/mac/drawingml/2011/main" xmlns:a14="http://schemas.microsoft.com/office/drawing/2010/main" xmlns:m="http://schemas.openxmlformats.org/officeDocument/2006/math" xmlns="" val="1"/>
+              <ma14:wrappingTextBoxFlag xmlns="" xmlns:m="http://schemas.openxmlformats.org/officeDocument/2006/math" xmlns:a14="http://schemas.microsoft.com/office/drawing/2010/main" xmlns:ma14="http://schemas.microsoft.com/office/mac/drawingml/2011/main" val="1"/>
             </a:ext>
           </a:extLst>
         </p:spPr>
@@ -1638,7 +1638,7 @@
           </a:ln>
           <a:extLst>
             <a:ext uri="{C572A759-6A51-4108-AA02-DFA0A04FC94B}">
-              <ma14:wrappingTextBoxFlag xmlns:ma14="http://schemas.microsoft.com/office/mac/drawingml/2011/main" xmlns:a14="http://schemas.microsoft.com/office/drawing/2010/main" xmlns:m="http://schemas.openxmlformats.org/officeDocument/2006/math" xmlns="" val="1"/>
+              <ma14:wrappingTextBoxFlag xmlns="" xmlns:m="http://schemas.openxmlformats.org/officeDocument/2006/math" xmlns:a14="http://schemas.microsoft.com/office/drawing/2010/main" xmlns:ma14="http://schemas.microsoft.com/office/mac/drawingml/2011/main" val="1"/>
             </a:ext>
           </a:extLst>
         </p:spPr>
@@ -1742,7 +1742,7 @@
           </a:ln>
           <a:extLst>
             <a:ext uri="{C572A759-6A51-4108-AA02-DFA0A04FC94B}">
-              <ma14:wrappingTextBoxFlag xmlns:ma14="http://schemas.microsoft.com/office/mac/drawingml/2011/main" xmlns:a14="http://schemas.microsoft.com/office/drawing/2010/main" xmlns:m="http://schemas.openxmlformats.org/officeDocument/2006/math" xmlns="" val="1"/>
+              <ma14:wrappingTextBoxFlag xmlns="" xmlns:m="http://schemas.openxmlformats.org/officeDocument/2006/math" xmlns:a14="http://schemas.microsoft.com/office/drawing/2010/main" xmlns:ma14="http://schemas.microsoft.com/office/mac/drawingml/2011/main" val="1"/>
             </a:ext>
           </a:extLst>
         </p:spPr>
@@ -1917,7 +1917,7 @@
           </a:ln>
           <a:extLst>
             <a:ext uri="{C572A759-6A51-4108-AA02-DFA0A04FC94B}">
-              <ma14:wrappingTextBoxFlag xmlns:ma14="http://schemas.microsoft.com/office/mac/drawingml/2011/main" xmlns:a14="http://schemas.microsoft.com/office/drawing/2010/main" xmlns:m="http://schemas.openxmlformats.org/officeDocument/2006/math" xmlns="" val="1"/>
+              <ma14:wrappingTextBoxFlag xmlns="" xmlns:m="http://schemas.openxmlformats.org/officeDocument/2006/math" xmlns:a14="http://schemas.microsoft.com/office/drawing/2010/main" xmlns:ma14="http://schemas.microsoft.com/office/mac/drawingml/2011/main" val="1"/>
             </a:ext>
           </a:extLst>
         </p:spPr>
@@ -1963,7 +1963,7 @@
           </a:ln>
           <a:extLst>
             <a:ext uri="{C572A759-6A51-4108-AA02-DFA0A04FC94B}">
-              <ma14:wrappingTextBoxFlag xmlns:ma14="http://schemas.microsoft.com/office/mac/drawingml/2011/main" xmlns:a14="http://schemas.microsoft.com/office/drawing/2010/main" xmlns:m="http://schemas.openxmlformats.org/officeDocument/2006/math" xmlns="" val="1"/>
+              <ma14:wrappingTextBoxFlag xmlns="" xmlns:m="http://schemas.openxmlformats.org/officeDocument/2006/math" xmlns:a14="http://schemas.microsoft.com/office/drawing/2010/main" xmlns:ma14="http://schemas.microsoft.com/office/mac/drawingml/2011/main" val="1"/>
             </a:ext>
           </a:extLst>
         </p:spPr>
@@ -2009,7 +2009,7 @@
           </a:ln>
           <a:extLst>
             <a:ext uri="{C572A759-6A51-4108-AA02-DFA0A04FC94B}">
-              <ma14:wrappingTextBoxFlag xmlns:ma14="http://schemas.microsoft.com/office/mac/drawingml/2011/main" xmlns:a14="http://schemas.microsoft.com/office/drawing/2010/main" xmlns:m="http://schemas.openxmlformats.org/officeDocument/2006/math" xmlns="" val="1"/>
+              <ma14:wrappingTextBoxFlag xmlns="" xmlns:m="http://schemas.openxmlformats.org/officeDocument/2006/math" xmlns:a14="http://schemas.microsoft.com/office/drawing/2010/main" xmlns:ma14="http://schemas.microsoft.com/office/mac/drawingml/2011/main" val="1"/>
             </a:ext>
           </a:extLst>
         </p:spPr>
@@ -2070,7 +2070,7 @@
           </a:ln>
           <a:extLst>
             <a:ext uri="{C572A759-6A51-4108-AA02-DFA0A04FC94B}">
-              <ma14:wrappingTextBoxFlag xmlns:ma14="http://schemas.microsoft.com/office/mac/drawingml/2011/main" xmlns:a14="http://schemas.microsoft.com/office/drawing/2010/main" xmlns:m="http://schemas.openxmlformats.org/officeDocument/2006/math" xmlns="" val="1"/>
+              <ma14:wrappingTextBoxFlag xmlns="" xmlns:m="http://schemas.openxmlformats.org/officeDocument/2006/math" xmlns:a14="http://schemas.microsoft.com/office/drawing/2010/main" xmlns:ma14="http://schemas.microsoft.com/office/mac/drawingml/2011/main" val="1"/>
             </a:ext>
           </a:extLst>
         </p:spPr>
@@ -2116,7 +2116,7 @@
           </a:ln>
           <a:extLst>
             <a:ext uri="{C572A759-6A51-4108-AA02-DFA0A04FC94B}">
-              <ma14:wrappingTextBoxFlag xmlns:ma14="http://schemas.microsoft.com/office/mac/drawingml/2011/main" xmlns:a14="http://schemas.microsoft.com/office/drawing/2010/main" xmlns:m="http://schemas.openxmlformats.org/officeDocument/2006/math" xmlns="" val="1"/>
+              <ma14:wrappingTextBoxFlag xmlns="" xmlns:m="http://schemas.openxmlformats.org/officeDocument/2006/math" xmlns:a14="http://schemas.microsoft.com/office/drawing/2010/main" xmlns:ma14="http://schemas.microsoft.com/office/mac/drawingml/2011/main" val="1"/>
             </a:ext>
           </a:extLst>
         </p:spPr>
@@ -2168,7 +2168,7 @@
           </a:ln>
           <a:extLst>
             <a:ext uri="{C572A759-6A51-4108-AA02-DFA0A04FC94B}">
-              <ma14:wrappingTextBoxFlag xmlns:ma14="http://schemas.microsoft.com/office/mac/drawingml/2011/main" xmlns:a14="http://schemas.microsoft.com/office/drawing/2010/main" xmlns:m="http://schemas.openxmlformats.org/officeDocument/2006/math" xmlns="" val="1"/>
+              <ma14:wrappingTextBoxFlag xmlns="" xmlns:m="http://schemas.openxmlformats.org/officeDocument/2006/math" xmlns:a14="http://schemas.microsoft.com/office/drawing/2010/main" xmlns:ma14="http://schemas.microsoft.com/office/mac/drawingml/2011/main" val="1"/>
             </a:ext>
           </a:extLst>
         </p:spPr>
@@ -2213,7 +2213,7 @@
           </a:ln>
           <a:extLst>
             <a:ext uri="{C572A759-6A51-4108-AA02-DFA0A04FC94B}">
-              <ma14:wrappingTextBoxFlag xmlns:ma14="http://schemas.microsoft.com/office/mac/drawingml/2011/main" xmlns:a14="http://schemas.microsoft.com/office/drawing/2010/main" xmlns:m="http://schemas.openxmlformats.org/officeDocument/2006/math" xmlns="" val="1"/>
+              <ma14:wrappingTextBoxFlag xmlns="" xmlns:m="http://schemas.openxmlformats.org/officeDocument/2006/math" xmlns:a14="http://schemas.microsoft.com/office/drawing/2010/main" xmlns:ma14="http://schemas.microsoft.com/office/mac/drawingml/2011/main" val="1"/>
             </a:ext>
           </a:extLst>
         </p:spPr>
@@ -2223,7 +2223,7 @@
           </a:bodyPr>
           <a:lstStyle/>
           <a:p>
-            <a:pPr>
+            <a:pPr algn="just">
               <a:lnSpc>
                 <a:spcPct val="120000"/>
               </a:lnSpc>
@@ -2261,6 +2261,7 @@
             </a:r>
           </a:p>
           <a:p>
+            <a:pPr algn="just"/>
             <a:r>
               <a:rPr lang="en-IN" sz="1400" dirty="0">
                 <a:latin typeface="Arial"/>
@@ -2298,6 +2299,7 @@
             </a:r>
           </a:p>
           <a:p>
+            <a:pPr algn="just"/>
             <a:r>
               <a:rPr lang="en-IN" sz="1400" dirty="0">
                 <a:latin typeface="Arial"/>
@@ -2321,6 +2323,7 @@
             </a:r>
           </a:p>
           <a:p>
+            <a:pPr algn="just"/>
             <a:r>
               <a:rPr lang="en-IN" sz="1400" dirty="0">
                 <a:latin typeface="Arial"/>
@@ -2344,6 +2347,7 @@
             </a:r>
           </a:p>
           <a:p>
+            <a:pPr algn="just"/>
             <a:r>
               <a:rPr lang="en-IN" sz="1400" dirty="0">
                 <a:latin typeface="Arial"/>
@@ -2353,6 +2357,7 @@
             </a:r>
           </a:p>
           <a:p>
+            <a:pPr algn="just"/>
             <a:r>
               <a:rPr lang="en-IN" sz="1400" dirty="0">
                 <a:latin typeface="Arial"/>
@@ -2362,7 +2367,7 @@
             </a:r>
           </a:p>
           <a:p>
-            <a:pPr marL="342900" indent="-342900">
+            <a:pPr marL="342900" indent="-342900" algn="just">
               <a:lnSpc>
                 <a:spcPct val="120000"/>
               </a:lnSpc>
@@ -2403,7 +2408,7 @@
           </a:ln>
           <a:extLst>
             <a:ext uri="{C572A759-6A51-4108-AA02-DFA0A04FC94B}">
-              <ma14:wrappingTextBoxFlag xmlns:ma14="http://schemas.microsoft.com/office/mac/drawingml/2011/main" xmlns:a14="http://schemas.microsoft.com/office/drawing/2010/main" xmlns:m="http://schemas.openxmlformats.org/officeDocument/2006/math" xmlns="" val="1"/>
+              <ma14:wrappingTextBoxFlag xmlns="" xmlns:m="http://schemas.openxmlformats.org/officeDocument/2006/math" xmlns:a14="http://schemas.microsoft.com/office/drawing/2010/main" xmlns:ma14="http://schemas.microsoft.com/office/mac/drawingml/2011/main" val="1"/>
             </a:ext>
           </a:extLst>
         </p:spPr>
@@ -2429,13 +2434,16 @@
             </a:pPr>
             <a:r>
               <a:rPr lang="en-US" dirty="0"/>
-              <a:t>Harsh Mukesh Sharma, Shikha Shashikant </a:t>
+              <a:t>Shikha </a:t>
             </a:r>
             <a:r>
               <a:rPr lang="en-US" dirty="0" err="1"/>
               <a:t>Masurkar</a:t>
             </a:r>
-            <a:endParaRPr lang="en-US" dirty="0"/>
+            <a:r>
+              <a:rPr lang="en-US" dirty="0"/>
+              <a:t>, Harsh Mukesh Sharma</a:t>
+            </a:r>
           </a:p>
         </p:txBody>
       </p:sp>
@@ -2620,7 +2628,7 @@
           </a:ln>
           <a:extLst>
             <a:ext uri="{C572A759-6A51-4108-AA02-DFA0A04FC94B}">
-              <ma14:wrappingTextBoxFlag xmlns:ma14="http://schemas.microsoft.com/office/mac/drawingml/2011/main" xmlns:a14="http://schemas.microsoft.com/office/drawing/2010/main" xmlns:m="http://schemas.openxmlformats.org/officeDocument/2006/math" xmlns="" xmlns:lc="http://schemas.openxmlformats.org/drawingml/2006/lockedCanvas" val="1"/>
+              <ma14:wrappingTextBoxFlag xmlns:lc="http://schemas.openxmlformats.org/drawingml/2006/lockedCanvas" xmlns="" xmlns:m="http://schemas.openxmlformats.org/officeDocument/2006/math" xmlns:a14="http://schemas.microsoft.com/office/drawing/2010/main" xmlns:ma14="http://schemas.microsoft.com/office/mac/drawingml/2011/main" val="1"/>
             </a:ext>
           </a:extLst>
         </p:spPr>
@@ -2968,7 +2976,7 @@
           </a:ln>
           <a:extLst>
             <a:ext uri="{C572A759-6A51-4108-AA02-DFA0A04FC94B}">
-              <ma14:wrappingTextBoxFlag xmlns:ma14="http://schemas.microsoft.com/office/mac/drawingml/2011/main" xmlns:a14="http://schemas.microsoft.com/office/drawing/2010/main" xmlns:m="http://schemas.openxmlformats.org/officeDocument/2006/math" xmlns="" xmlns:lc="http://schemas.openxmlformats.org/drawingml/2006/lockedCanvas" val="1"/>
+              <ma14:wrappingTextBoxFlag xmlns:lc="http://schemas.openxmlformats.org/drawingml/2006/lockedCanvas" xmlns="" xmlns:m="http://schemas.openxmlformats.org/officeDocument/2006/math" xmlns:a14="http://schemas.microsoft.com/office/drawing/2010/main" xmlns:ma14="http://schemas.microsoft.com/office/mac/drawingml/2011/main" val="1"/>
             </a:ext>
           </a:extLst>
         </p:spPr>
@@ -3308,7 +3316,7 @@
           </a:ln>
           <a:extLst>
             <a:ext uri="{C572A759-6A51-4108-AA02-DFA0A04FC94B}">
-              <ma14:wrappingTextBoxFlag xmlns:ma14="http://schemas.microsoft.com/office/mac/drawingml/2011/main" xmlns:a14="http://schemas.microsoft.com/office/drawing/2010/main" xmlns:m="http://schemas.openxmlformats.org/officeDocument/2006/math" xmlns="" xmlns:lc="http://schemas.openxmlformats.org/drawingml/2006/lockedCanvas" val="1"/>
+              <ma14:wrappingTextBoxFlag xmlns:lc="http://schemas.openxmlformats.org/drawingml/2006/lockedCanvas" xmlns="" xmlns:m="http://schemas.openxmlformats.org/officeDocument/2006/math" xmlns:a14="http://schemas.microsoft.com/office/drawing/2010/main" xmlns:ma14="http://schemas.microsoft.com/office/mac/drawingml/2011/main" val="1"/>
             </a:ext>
           </a:extLst>
         </p:spPr>
@@ -3648,7 +3656,7 @@
           </a:ln>
           <a:extLst>
             <a:ext uri="{C572A759-6A51-4108-AA02-DFA0A04FC94B}">
-              <ma14:wrappingTextBoxFlag xmlns:ma14="http://schemas.microsoft.com/office/mac/drawingml/2011/main" xmlns:a14="http://schemas.microsoft.com/office/drawing/2010/main" xmlns:m="http://schemas.openxmlformats.org/officeDocument/2006/math" xmlns="" xmlns:lc="http://schemas.openxmlformats.org/drawingml/2006/lockedCanvas" val="1"/>
+              <ma14:wrappingTextBoxFlag xmlns:lc="http://schemas.openxmlformats.org/drawingml/2006/lockedCanvas" xmlns="" xmlns:m="http://schemas.openxmlformats.org/officeDocument/2006/math" xmlns:a14="http://schemas.microsoft.com/office/drawing/2010/main" xmlns:ma14="http://schemas.microsoft.com/office/mac/drawingml/2011/main" val="1"/>
             </a:ext>
           </a:extLst>
         </p:spPr>

</xml_diff>